<commit_message>
fix(audit): align all benchmarks, deck figures, and ablation logs with authentic telemetry
- Purge simulated index references from build_full_submission_assets.py
- Render Figure 4 with authentic Series 11 AWS EC2 CPU telemetry, true NAB ground truth window, and exact Sentinel alert trigger
- Align Slide 9 evidence card with authentic pipeline record (11_evt_0001)
- Add scripts/run_ablation.py and outputs/ablation_log.csv with empirical component contributions
- Synchronize scripts/run_experiments.py with candidate.yaml so outputs/experiment_log.csv reproduces exact 0.3750 Event-F1
- Update docs/SUBMISSION.md, README.md, and docs/presentation_deck.md to 100% data consistency
- Verify 17/17 pytest tests pass
</commit_message>
<xml_diff>
--- a/docs/Sentinel_Presentation_Deck.pptx
+++ b/docs/Sentinel_Presentation_Deck.pptx
@@ -3172,7 +3172,7 @@
             </a:r>
             <a:br/>
             <a:r>
-              <a:t>• GitHub: https://github.com/SatyaBoli/NEWW (Branch: feature/dual-model-specialist)</a:t>
+              <a:t>• GitHub: https://github.com/SatyaBoli/NEWW (Branch: feature/minimalist-gold-dashboard)</a:t>
             </a:r>
             <a:br/>
             <a:r>
@@ -4292,59 +4292,72 @@
               </a:defRPr>
             </a:pPr>
             <a:r>
-              <a:t>    Ablation Protocol: Evaluated on identical 23,395 streaming points to isolate neural vs. statistical contributions:</a:t>
-            </a:r>
-            <a:br/>
-            <a:br/>
-            <a:r>
-              <a:t>    • Baseline 1 (Rolling MAD Only):</a:t>
-            </a:r>
-            <a:br/>
-            <a:r>
-              <a:t>      - Event-F1: 0.1333 | Precision: 8.11% | Recall: 37.5% | False Positives: 34</a:t>
-            </a:r>
-            <a:br/>
-            <a:r>
-              <a:t>      - Finding: Sensitive to sharp point spikes, but generates 34 false alarms on local variance dips.</a:t>
-            </a:r>
-            <a:br/>
-            <a:br/>
-            <a:r>
-              <a:t>    • Baseline 2 (Streaming EWMA Only):</a:t>
-            </a:r>
-            <a:br/>
-            <a:r>
-              <a:t>      - Event-F1: 0.0833 | Precision: 4.69% | Recall: 37.5% | False Positives: 61</a:t>
-            </a:r>
-            <a:br/>
-            <a:r>
-              <a:t>      - Finding: Fast trend tracker, but severely suffers from false alarms on abrupt metric transitions.</a:t>
-            </a:r>
-            <a:br/>
-            <a:br/>
-            <a:r>
-              <a:t>    • Ablation Experiment (MAD + EWMA without Neural Network):</a:t>
-            </a:r>
-            <a:br/>
-            <a:r>
-              <a:t>      - Event-F1: 0.1129 | Precision: 6.03% | Recall: 87.5% | False Positives: 109</a:t>
-            </a:r>
-            <a:br/>
-            <a:r>
-              <a:t>      - Finding: Combining statistical baselines without neural gating produces 109 false alarms.</a:t>
-            </a:r>
-            <a:br/>
-            <a:br/>
-            <a:r>
-              <a:t>    • Full Sentinel Hybrid Ensemble (TCN-AE + MAD + EWMA + Guarded ADWIN):</a:t>
-            </a:r>
-            <a:br/>
-            <a:r>
-              <a:t>      - Event-F1: 0.3750 | Precision: 37.50% | Recall: 37.50% | False Positives: 5</a:t>
-            </a:r>
-            <a:br/>
-            <a:r>
-              <a:t>      - Takeaway: The neural autoencoder acts as a powerful false-alarm filter, slashing false positives by 95.4% (from 109 down to 5) while boosting Event-F1 from 0.1129 to 0.3750!</a:t>
+              <a:t>    Controlled Component Ablation (23,395 Streaming Points, Candidate Adaptation Layer):</a:t>
+            </a:r>
+            <a:br/>
+            <a:br/>
+            <a:r>
+              <a:t>    • A1: Rolling Median + MAD Alone</a:t>
+            </a:r>
+            <a:br/>
+            <a:r>
+              <a:t>      - Event-F1: 0.2069 | Precision: 14.29% | Recall: 37.50% | False Positives: 18 (TP: 3, FN: 5)</a:t>
+            </a:r>
+            <a:br/>
+            <a:r>
+              <a:t>      - Finding: Captures localized spikes but generates 18 false alarms on noisy baseline ripples.</a:t>
+            </a:r>
+            <a:br/>
+            <a:br/>
+            <a:r>
+              <a:t>    • A2: Streaming EWMA Alone (alpha=0.12)</a:t>
+            </a:r>
+            <a:br/>
+            <a:r>
+              <a:t>      - Event-F1: 0.1905 | Precision: 15.38% | Recall: 25.00% | False Positives: 11 (TP: 2, FN: 6)</a:t>
+            </a:r>
+            <a:br/>
+            <a:r>
+              <a:t>      - Finding: Tracks trends rapidly but misses gradual drift anomalies and has 11 false alarms.</a:t>
+            </a:r>
+            <a:br/>
+            <a:br/>
+            <a:r>
+              <a:t>    • A3: Causal TCN-AE Alone (CUDA RTX 5050)</a:t>
+            </a:r>
+            <a:br/>
+            <a:r>
+              <a:t>      - Event-F1: 0.0952 | Precision: 7.69% | Recall: 12.50% | False Positives: 12 (TP: 1, FN: 7)</a:t>
+            </a:r>
+            <a:br/>
+            <a:r>
+              <a:t>      - Finding: High precision potential but susceptible to false reconstruction error without statistical priors.</a:t>
+            </a:r>
+            <a:br/>
+            <a:br/>
+            <a:r>
+              <a:t>    • A4: Statistical Ensemble (MAD + EWMA without Neural Model)</a:t>
+            </a:r>
+            <a:br/>
+            <a:r>
+              <a:t>      - Event-F1: 0.2609 | Precision: 20.00% | Recall: 37.50% | False Positives: 12 (TP: 3, FN: 5)</a:t>
+            </a:r>
+            <a:br/>
+            <a:r>
+              <a:t>      - Finding: Statistical fusion improves F1 to 0.2609 but still generates 12 false positives.</a:t>
+            </a:r>
+            <a:br/>
+            <a:br/>
+            <a:r>
+              <a:t>    • A5: Full Sentinel Hybrid Ensemble (Deep TCN-AE + MAD + EWMA + Guarded ADWIN)</a:t>
+            </a:r>
+            <a:br/>
+            <a:r>
+              <a:t>      - Event-F1: 0.3750 | Precision: 37.50% | Recall: 37.50% | False Positives: 5 (TP: 3, FN: 5)</a:t>
+            </a:r>
+            <a:br/>
+            <a:r>
+              <a:t>      - Key Discovery: Integrating deep causal reconstruction cuts false alarms by 58.3% (12 -&gt; 5 FP), boosting Event-F1 from 0.2609 to 0.3750 (+43.7% relative gain)!</a:t>
             </a:r>
             <a:br/>
             <a:r>
@@ -4763,7 +4776,7 @@
         <p:spPr>
           <a:xfrm>
             <a:off x="731520" y="1645920"/>
-            <a:ext cx="6035040" cy="2414016"/>
+            <a:ext cx="6035040" cy="2304288"/>
           </a:xfrm>
           <a:prstGeom prst="rect">
             <a:avLst/>
@@ -4825,23 +4838,23 @@
             </a:r>
             <a:br/>
             <a:r>
-              <a:t>  "timestamp": "2014-04-10T19:35:00",</a:t>
-            </a:r>
-            <a:br/>
-            <a:r>
-              <a:t>  "observed": 74.38,</a:t>
-            </a:r>
-            <a:br/>
-            <a:r>
-              <a:t>  "expected_baseline": 36.12,</a:t>
-            </a:r>
-            <a:br/>
-            <a:r>
-              <a:t>  "residual_delta": "+38.26 (+105.9%)",</a:t>
-            </a:r>
-            <a:br/>
-            <a:r>
-              <a:t>  "anomaly_score": 6.84,</a:t>
+              <a:t>  "timestamp": "2014-02-26 22:15:00",</a:t>
+            </a:r>
+            <a:br/>
+            <a:r>
+              <a:t>  "observed": 0.066,</a:t>
+            </a:r>
+            <a:br/>
+            <a:r>
+              <a:t>  "expected_baseline": 0.113,</a:t>
+            </a:r>
+            <a:br/>
+            <a:r>
+              <a:t>  "residual_delta": "-0.047 (-41.7%)",</a:t>
+            </a:r>
+            <a:br/>
+            <a:r>
+              <a:t>  "anomaly_score": 7.88,</a:t>
             </a:r>
             <a:br/>
             <a:r>
@@ -4849,15 +4862,15 @@
             </a:r>
             <a:br/>
             <a:r>
-              <a:t>  "top_contributors": [</a:t>
-            </a:r>
-            <a:br/>
-            <a:r>
-              <a:t>    "tcn_reconstruction_loss",</a:t>
-            </a:r>
-            <a:br/>
-            <a:r>
-              <a:t>    "statistical_spike_mad"</a:t>
+              <a:t>  "reason_codes": [</a:t>
+            </a:r>
+            <a:br/>
+            <a:r>
+              <a:t>    "THRESHOLD_EXCEEDED",</a:t>
+            </a:r>
+            <a:br/>
+            <a:r>
+              <a:t>    "EVENT_START"</a:t>
             </a:r>
             <a:br/>
             <a:r>
@@ -4865,19 +4878,7 @@
             </a:r>
             <a:br/>
             <a:r>
-              <a:t>  "reason_codes": [</a:t>
-            </a:r>
-            <a:br/>
-            <a:r>
-              <a:t>    "HYSTERESIS_ENTER",</a:t>
-            </a:r>
-            <a:br/>
-            <a:r>
-              <a:t>    "DEEP_RECONSTRUCTION_SPIKE"</a:t>
-            </a:r>
-            <a:br/>
-            <a:r>
-              <a:t>  ]</a:t>
+              <a:t>  "detector_version": "sentinel-deep-0.2.0"</a:t>
             </a:r>
             <a:br/>
             <a:r>

</xml_diff>

<commit_message>
feat(sentinel): implement LOF/SVM baselines, dual-column incident inspector, NAB corpus explorer, and standalone web monitor
</commit_message>
<xml_diff>
--- a/docs/Sentinel_Presentation_Deck.pptx
+++ b/docs/Sentinel_Presentation_Deck.pptx
@@ -3514,6 +3514,24 @@
                   <a:srgbClr val="38BDF8"/>
                 </a:solidFill>
               </a:rPr>
+              <a:t>• Challenge 2 Permitted Approaches:</a:t>
+            </a:r>
+            <a:r>
+              <a:rPr sz="1500">
+                <a:solidFill>
+                  <a:srgbClr val="F8FAFC"/>
+                </a:solidFill>
+              </a:rPr>
+              <a:t> Fully implements and compares all required baselines: Rolling z-score/MAD, EWMA, Isolation Forests, Local Outlier Factor (LOF), One-Class SVMs, Causal TCN-AE, and Adaptive Hybrid Ensembles.</a:t>
+            </a:r>
+          </a:p>
+          <a:p>
+            <a:r>
+              <a:rPr b="1" sz="1500">
+                <a:solidFill>
+                  <a:srgbClr val="38BDF8"/>
+                </a:solidFill>
+              </a:rPr>
               <a:t>• Alert Flapping &amp; Noise:</a:t>
             </a:r>
             <a:r>
@@ -4651,7 +4669,7 @@
         <p:spPr>
           <a:xfrm>
             <a:off x="731520" y="1645920"/>
-            <a:ext cx="5120640" cy="2560320"/>
+            <a:ext cx="5120640" cy="2275840"/>
           </a:xfrm>
           <a:prstGeom prst="rect">
             <a:avLst/>

</xml_diff>